<commit_message>
docs(present): head-to-head slide leads with round 2 — all arms, all three rounds
The showcase deck's head-to-head slide now charts the latest round's full four-arm table
(ripwire 58.3 · repowise 33.3 · codeseek ident 15.0 · codeseek raw 0.0, the zero kept
on-chart with its protocol-boundary footnote), with round 1's four-tool table and the
not-number-comparable rule in the history card and round 3 (headroom, tokens instrument)
in a third. Slide 2's stat card moves to the r2 median (0.114 s) with its provenance
footer repointed at r2-2026-08-03/. Generator-built; validate + ripwirepubliccheck green.

Co-Authored-By: Claude Fable 5 <noreply@anthropic.com>
</commit_message>
<xml_diff>
--- a/present/ripwire-showcase.pptx
+++ b/present/ripwire-showcase.pptx
@@ -235,13 +235,13 @@
                     <c:v>ripwire --for</c:v>
                   </c:pt>
                   <c:pt idx="1">
-                    <c:v>codebase-memory-mcp</c:v>
+                    <c:v>repowise 0.37.0</c:v>
                   </c:pt>
                   <c:pt idx="2">
-                    <c:v>graphify</c:v>
+                    <c:v>codeseek 0.1.31 (ident arm)</c:v>
                   </c:pt>
                   <c:pt idx="3">
-                    <c:v>Aider repo-map</c:v>
+                    <c:v>codeseek 0.1.31 (raw fallback)</c:v>
                   </c:pt>
                 </c:lvl>
               </c:multiLvlStrCache>
@@ -254,16 +254,16 @@
                 <c:formatCode>General</c:formatCode>
                 <c:ptCount val="4"/>
                 <c:pt idx="0">
-                  <c:v>36.7</c:v>
+                  <c:v>58.3</c:v>
                 </c:pt>
                 <c:pt idx="1">
-                  <c:v>26.7</c:v>
+                  <c:v>33.3</c:v>
                 </c:pt>
                 <c:pt idx="2">
-                  <c:v>21.7</c:v>
+                  <c:v>15</c:v>
                 </c:pt>
                 <c:pt idx="3">
-                  <c:v>13.3</c:v>
+                  <c:v>0</c:v>
                 </c:pt>
               </c:numCache>
             </c:numRef>
@@ -344,7 +344,7 @@
         <c:axId val="2094734552"/>
         <c:scaling>
           <c:orientation val="minMax"/>
-          <c:max val="40"/>
+          <c:max val="70"/>
           <c:min val="0"/>
         </c:scaling>
         <c:delete val="0"/>
@@ -10862,7 +10862,7 @@
                 <a:ea typeface="Arial" pitchFamily="34" charset="-122"/>
                 <a:cs typeface="Arial" pitchFamily="34" charset="-120"/>
               </a:rPr>
-              <a:t>0.074 s</a:t>
+              <a:t>0.114 s</a:t>
             </a:r>
             <a:endParaRPr lang="en-US" sz="4400" dirty="0"/>
           </a:p>
@@ -10901,7 +10901,7 @@
                 <a:ea typeface="Arial" pitchFamily="34" charset="-122"/>
                 <a:cs typeface="Arial" pitchFamily="34" charset="-120"/>
               </a:rPr>
-              <a:t>median answer, warm index — head-to-head, N = 60</a:t>
+              <a:t>median answer, warm index — latest head-to-head round, N = 60</a:t>
             </a:r>
             <a:endParaRPr lang="en-US" sz="1250" dirty="0"/>
           </a:p>
@@ -11084,7 +11084,7 @@
                 <a:ea typeface="Courier New" pitchFamily="34" charset="-122"/>
                 <a:cs typeface="Courier New" pitchFamily="34" charset="-120"/>
               </a:rPr>
-              <a:t>bench/headtohead/REPORT.md · bench/locbench/ — every figure on this deck names its instrument</a:t>
+              <a:t>bench/headtohead/r2-2026-08-03/ · bench/locbench/ — every figure on this deck names its instrument</a:t>
             </a:r>
             <a:endParaRPr lang="en-US" sz="1050" dirty="0"/>
           </a:p>
@@ -14824,7 +14824,7 @@
                 <a:ea typeface="Arial" pitchFamily="34" charset="-122"/>
                 <a:cs typeface="Arial" pitchFamily="34" charset="-120"/>
               </a:rPr>
-              <a:t>Head-to-head: strict localization, four tools</a:t>
+              <a:t>Head-to-head: strict localization, latest round</a:t>
             </a:r>
             <a:endParaRPr lang="en-US" sz="3400" dirty="0"/>
           </a:p>
@@ -14838,7 +14838,7 @@
         </p:nvGraphicFramePr>
         <p:xfrm>
           <a:off x="566928" y="1783080"/>
-          <a:ext cx="6675120" cy="3931920"/>
+          <a:ext cx="6675120" cy="3566160"/>
         </p:xfrm>
         <a:graphic xmlns:a="http://schemas.openxmlformats.org/drawingml/2006/main">
           <a:graphicData uri="http://schemas.openxmlformats.org/drawingml/2006/chart">
@@ -14848,18 +14848,57 @@
       </p:graphicFrame>
       <p:sp>
         <p:nvSpPr>
-          <p:cNvPr id="5" name="Shape 2"/>
+          <p:cNvPr id="5" name="Text 2"/>
+          <p:cNvSpPr/>
+          <p:nvPr/>
+        </p:nvSpPr>
+        <p:spPr>
+          <a:xfrm>
+            <a:off x="566928" y="5440680"/>
+            <a:ext cx="6675120" cy="777240"/>
+          </a:xfrm>
+          <a:prstGeom prst="rect">
+            <a:avLst/>
+          </a:prstGeom>
+          <a:noFill/>
+          <a:ln/>
+        </p:spPr>
+        <p:txBody>
+          <a:bodyPr wrap="square" lIns="0" tIns="0" rIns="0" bIns="0" rtlCol="0" anchor="ctr"/>
+          <a:lstStyle/>
+          <a:p>
+            <a:pPr indent="0" marL="0">
+              <a:buNone/>
+            </a:pPr>
+            <a:r>
+              <a:rPr lang="en-US" sz="1050" dirty="0">
+                <a:solidFill>
+                  <a:srgbClr val="8B95A5"/>
+                </a:solidFill>
+                <a:latin typeface="Arial" pitchFamily="34" charset="0"/>
+                <a:ea typeface="Arial" pitchFamily="34" charset="-122"/>
+                <a:cs typeface="Arial" pitchFamily="34" charset="-120"/>
+              </a:rPr>
+              <a:t>codeseek's keyless raw-text arm scored 0.0% (0 results on 60/60) — a query-protocol boundary, not its embedder mode. Vexp and CodeIndexer were excluded by free-tier caps, not beaten; the report records the exact limits.</a:t>
+            </a:r>
+            <a:endParaRPr lang="en-US" sz="1050" dirty="0"/>
+          </a:p>
+        </p:txBody>
+      </p:sp>
+      <p:sp>
+        <p:nvSpPr>
+          <p:cNvPr id="6" name="Shape 3"/>
           <p:cNvSpPr/>
           <p:nvPr/>
         </p:nvSpPr>
         <p:spPr>
           <a:xfrm>
             <a:off x="7498080" y="1783080"/>
-            <a:ext cx="4023360" cy="1783080"/>
+            <a:ext cx="4023360" cy="1554480"/>
           </a:xfrm>
           <a:prstGeom prst="roundRect">
             <a:avLst>
-              <a:gd name="adj" fmla="val 4615"/>
+              <a:gd name="adj" fmla="val 5294"/>
             </a:avLst>
           </a:prstGeom>
           <a:solidFill>
@@ -14875,13 +14914,13 @@
       </p:sp>
       <p:sp>
         <p:nvSpPr>
-          <p:cNvPr id="6" name="Text 3"/>
-          <p:cNvSpPr/>
-          <p:nvPr/>
-        </p:nvSpPr>
-        <p:spPr>
-          <a:xfrm>
-            <a:off x="7589520" y="1965960"/>
+          <p:cNvPr id="7" name="Text 4"/>
+          <p:cNvSpPr/>
+          <p:nvPr/>
+        </p:nvSpPr>
+        <p:spPr>
+          <a:xfrm>
+            <a:off x="7589520" y="1920240"/>
             <a:ext cx="3840480" cy="868680"/>
           </a:xfrm>
           <a:prstGeom prst="rect">
@@ -14906,7 +14945,7 @@
                 <a:ea typeface="Arial" pitchFamily="34" charset="-122"/>
                 <a:cs typeface="Arial" pitchFamily="34" charset="-120"/>
               </a:rPr>
-              <a:t>36.7%</a:t>
+              <a:t>58.3%</a:t>
             </a:r>
             <a:endParaRPr lang="en-US" sz="4400" dirty="0"/>
           </a:p>
@@ -14914,13 +14953,13 @@
       </p:sp>
       <p:sp>
         <p:nvSpPr>
-          <p:cNvPr id="7" name="Text 4"/>
-          <p:cNvSpPr/>
-          <p:nvPr/>
-        </p:nvSpPr>
-        <p:spPr>
-          <a:xfrm>
-            <a:off x="7589520" y="2779776"/>
+          <p:cNvPr id="8" name="Text 5"/>
+          <p:cNvSpPr/>
+          <p:nvPr/>
+        </p:nvSpPr>
+        <p:spPr>
+          <a:xfrm>
+            <a:off x="7589520" y="2734056"/>
             <a:ext cx="3840480" cy="685800"/>
           </a:xfrm>
           <a:prstGeom prst="rect">
@@ -14937,7 +14976,7 @@
               <a:buNone/>
             </a:pPr>
             <a:r>
-              <a:rPr lang="en-US" sz="1150" dirty="0">
+              <a:rPr lang="en-US" sz="1100" dirty="0">
                 <a:solidFill>
                   <a:srgbClr val="8B95A5"/>
                 </a:solidFill>
@@ -14947,14 +14986,14 @@
               </a:rPr>
               <a:t>strict file@10 — every gold file in the top ten</a:t>
             </a:r>
-            <a:endParaRPr lang="en-US" sz="1150" dirty="0"/>
+            <a:endParaRPr lang="en-US" sz="1100" dirty="0"/>
           </a:p>
           <a:p>
             <a:pPr algn="ctr" indent="0" marL="0">
               <a:buNone/>
             </a:pPr>
             <a:r>
-              <a:rPr lang="en-US" sz="1150" dirty="0">
+              <a:rPr lang="en-US" sz="1100" dirty="0">
                 <a:solidFill>
                   <a:srgbClr val="8B95A5"/>
                 </a:solidFill>
@@ -14962,26 +15001,26 @@
                 <a:ea typeface="Arial" pitchFamily="34" charset="-122"/>
                 <a:cs typeface="Arial" pitchFamily="34" charset="-120"/>
               </a:rPr>
-              <a:t>N = 60 paired, zero exclusions</a:t>
-            </a:r>
-            <a:endParaRPr lang="en-US" sz="1150" dirty="0"/>
-          </a:p>
-        </p:txBody>
-      </p:sp>
-      <p:sp>
-        <p:nvSpPr>
-          <p:cNvPr id="8" name="Shape 5"/>
-          <p:cNvSpPr/>
-          <p:nvPr/>
-        </p:nvSpPr>
-        <p:spPr>
-          <a:xfrm>
-            <a:off x="7498080" y="3749040"/>
-            <a:ext cx="4023360" cy="1965960"/>
+              <a:t>N = 60 paired, zero exclusions · 17–2 paired vs repowise</a:t>
+            </a:r>
+            <a:endParaRPr lang="en-US" sz="1100" dirty="0"/>
+          </a:p>
+        </p:txBody>
+      </p:sp>
+      <p:sp>
+        <p:nvSpPr>
+          <p:cNvPr id="9" name="Shape 6"/>
+          <p:cNvSpPr/>
+          <p:nvPr/>
+        </p:nvSpPr>
+        <p:spPr>
+          <a:xfrm>
+            <a:off x="7498080" y="3474720"/>
+            <a:ext cx="4023360" cy="1371600"/>
           </a:xfrm>
           <a:prstGeom prst="roundRect">
             <a:avLst>
-              <a:gd name="adj" fmla="val 4186"/>
+              <a:gd name="adj" fmla="val 6000"/>
             </a:avLst>
           </a:prstGeom>
           <a:solidFill>
@@ -14997,30 +15036,30 @@
       </p:sp>
       <p:sp>
         <p:nvSpPr>
-          <p:cNvPr id="9" name="Text 6"/>
-          <p:cNvSpPr/>
-          <p:nvPr/>
-        </p:nvSpPr>
-        <p:spPr>
-          <a:xfrm>
-            <a:off x="7680960" y="3886200"/>
-            <a:ext cx="3657600" cy="292608"/>
-          </a:xfrm>
-          <a:prstGeom prst="rect">
-            <a:avLst/>
-          </a:prstGeom>
-          <a:noFill/>
-          <a:ln/>
-        </p:spPr>
-        <p:txBody>
-          <a:bodyPr wrap="square" lIns="0" tIns="0" rIns="0" bIns="0" rtlCol="0" anchor="ctr"/>
-          <a:lstStyle/>
-          <a:p>
-            <a:pPr indent="0" marL="0">
-              <a:buNone/>
-            </a:pPr>
-            <a:r>
-              <a:rPr lang="en-US" sz="1250" b="1" dirty="0">
+          <p:cNvPr id="10" name="Text 7"/>
+          <p:cNvSpPr/>
+          <p:nvPr/>
+        </p:nvSpPr>
+        <p:spPr>
+          <a:xfrm>
+            <a:off x="7680960" y="3593592"/>
+            <a:ext cx="3703320" cy="1188720"/>
+          </a:xfrm>
+          <a:prstGeom prst="rect">
+            <a:avLst/>
+          </a:prstGeom>
+          <a:noFill/>
+          <a:ln/>
+        </p:spPr>
+        <p:txBody>
+          <a:bodyPr wrap="square" lIns="0" tIns="0" rIns="0" bIns="0" rtlCol="0" anchor="ctr"/>
+          <a:lstStyle/>
+          <a:p>
+            <a:pPr indent="0" marL="0">
+              <a:buNone/>
+            </a:pPr>
+            <a:r>
+              <a:rPr lang="en-US" sz="1050" b="1" dirty="0">
                 <a:solidFill>
                   <a:srgbClr val="E6EDF3"/>
                 </a:solidFill>
@@ -15028,38 +15067,13 @@
                 <a:ea typeface="Arial" pitchFamily="34" charset="-122"/>
                 <a:cs typeface="Arial" pitchFamily="34" charset="-120"/>
               </a:rPr>
-              <a:t>Median wall clock</a:t>
-            </a:r>
-            <a:endParaRPr lang="en-US" sz="1250" dirty="0"/>
-          </a:p>
-        </p:txBody>
-      </p:sp>
-      <p:sp>
-        <p:nvSpPr>
-          <p:cNvPr id="10" name="Text 7"/>
-          <p:cNvSpPr/>
-          <p:nvPr/>
-        </p:nvSpPr>
-        <p:spPr>
-          <a:xfrm>
-            <a:off x="7680960" y="4206240"/>
-            <a:ext cx="3703320" cy="1417320"/>
-          </a:xfrm>
-          <a:prstGeom prst="rect">
-            <a:avLst/>
-          </a:prstGeom>
-          <a:noFill/>
-          <a:ln/>
-        </p:spPr>
-        <p:txBody>
-          <a:bodyPr wrap="square" lIns="0" tIns="0" rIns="0" bIns="0" rtlCol="0" anchor="ctr"/>
-          <a:lstStyle/>
-          <a:p>
-            <a:pPr indent="0" marL="0">
-              <a:buNone/>
-            </a:pPr>
-            <a:r>
-              <a:rPr lang="en-US" sz="1150" dirty="0">
+              <a:t>Median wall (query, warm): </a:t>
+            </a:r>
+            <a:pPr indent="0" marL="0">
+              <a:buNone/>
+            </a:pPr>
+            <a:r>
+              <a:rPr lang="en-US" sz="1050" dirty="0">
                 <a:solidFill>
                   <a:srgbClr val="8B95A5"/>
                 </a:solidFill>
@@ -15067,22 +15081,14 @@
                 <a:ea typeface="Arial" pitchFamily="34" charset="-122"/>
                 <a:cs typeface="Arial" pitchFamily="34" charset="-120"/>
               </a:rPr>
-              <a:t>ripwire 0.074 s · cmm 1.14 s · Aider 2.5 s · graphify 5.8 s</a:t>
-            </a:r>
-            <a:endParaRPr lang="en-US" sz="1150" dirty="0"/>
-          </a:p>
-          <a:p>
-            <a:pPr indent="0" marL="0">
-              <a:buNone/>
-            </a:pPr>
-            <a:endParaRPr lang="en-US" sz="1150" dirty="0"/>
-          </a:p>
-          <a:p>
-            <a:pPr indent="0" marL="0">
-              <a:buNone/>
-            </a:pPr>
-            <a:r>
-              <a:rPr lang="en-US" sz="1150" dirty="0">
+              <a:t>ripwire 0.114 s · repowise 1.14 s (incl. a fresh MCP-server spawn per query).
+</a:t>
+            </a:r>
+            <a:pPr indent="0" marL="0">
+              <a:buNone/>
+            </a:pPr>
+            <a:r>
+              <a:rPr lang="en-US" sz="1050" dirty="0">
                 <a:solidFill>
                   <a:srgbClr val="8B95A5"/>
                 </a:solidFill>
@@ -15090,15 +15096,95 @@
                 <a:ea typeface="Arial" pitchFamily="34" charset="-122"/>
                 <a:cs typeface="Arial" pitchFamily="34" charset="-120"/>
               </a:rPr>
-              <a:t>≈34× vs Aider is derived from those medians — and the caveat ships with it: ripwire is warm on a pre-built index.</a:t>
-            </a:r>
-            <a:endParaRPr lang="en-US" sz="1150" dirty="0"/>
-          </a:p>
-        </p:txBody>
-      </p:sp>
-      <p:sp>
-        <p:nvSpPr>
-          <p:cNvPr id="11" name="Text 8"/>
+              <a:t>Round 1, four tools: 36.7% vs cmm 26.7 · graphify 21.7 · Aider 13.3 — each round is internally paired; rounds are not number-comparable.</a:t>
+            </a:r>
+            <a:endParaRPr lang="en-US" sz="1050" dirty="0"/>
+          </a:p>
+        </p:txBody>
+      </p:sp>
+      <p:sp>
+        <p:nvSpPr>
+          <p:cNvPr id="11" name="Shape 8"/>
+          <p:cNvSpPr/>
+          <p:nvPr/>
+        </p:nvSpPr>
+        <p:spPr>
+          <a:xfrm>
+            <a:off x="7498080" y="4983480"/>
+            <a:ext cx="4023360" cy="1051560"/>
+          </a:xfrm>
+          <a:prstGeom prst="roundRect">
+            <a:avLst>
+              <a:gd name="adj" fmla="val 7826"/>
+            </a:avLst>
+          </a:prstGeom>
+          <a:solidFill>
+            <a:srgbClr val="161D28"/>
+          </a:solidFill>
+          <a:ln w="9525">
+            <a:solidFill>
+              <a:srgbClr val="232D3D"/>
+            </a:solidFill>
+            <a:prstDash val="solid"/>
+          </a:ln>
+        </p:spPr>
+      </p:sp>
+      <p:sp>
+        <p:nvSpPr>
+          <p:cNvPr id="12" name="Text 9"/>
+          <p:cNvSpPr/>
+          <p:nvPr/>
+        </p:nvSpPr>
+        <p:spPr>
+          <a:xfrm>
+            <a:off x="7680960" y="5084064"/>
+            <a:ext cx="3703320" cy="896112"/>
+          </a:xfrm>
+          <a:prstGeom prst="rect">
+            <a:avLst/>
+          </a:prstGeom>
+          <a:noFill/>
+          <a:ln/>
+        </p:spPr>
+        <p:txBody>
+          <a:bodyPr wrap="square" lIns="0" tIns="0" rIns="0" bIns="0" rtlCol="0" anchor="ctr"/>
+          <a:lstStyle/>
+          <a:p>
+            <a:pPr indent="0" marL="0">
+              <a:buNone/>
+            </a:pPr>
+            <a:r>
+              <a:rPr lang="en-US" sz="1050" b="1" dirty="0">
+                <a:solidFill>
+                  <a:srgbClr val="E6EDF3"/>
+                </a:solidFill>
+                <a:latin typeface="Arial" pitchFamily="34" charset="0"/>
+                <a:ea typeface="Arial" pitchFamily="34" charset="-122"/>
+                <a:cs typeface="Arial" pitchFamily="34" charset="-120"/>
+              </a:rPr>
+              <a:t>Round 3, different instrument: </a:t>
+            </a:r>
+            <a:pPr indent="0" marL="0">
+              <a:buNone/>
+            </a:pPr>
+            <a:r>
+              <a:rPr lang="en-US" sz="1050" dirty="0">
+                <a:solidFill>
+                  <a:srgbClr val="8B95A5"/>
+                </a:solidFill>
+                <a:latin typeface="Arial" pitchFamily="34" charset="0"/>
+                <a:ea typeface="Arial" pitchFamily="34" charset="-122"/>
+                <a:cs typeface="Arial" pitchFamily="34" charset="-120"/>
+              </a:rPr>
+              <a:t>headroom (the compression layer) passed code through byte-identical; ripwire answered at 7.3% of the naive baseline's tokens. Its own losses ship first in that report.</a:t>
+            </a:r>
+            <a:endParaRPr lang="en-US" sz="1050" dirty="0"/>
+          </a:p>
+        </p:txBody>
+      </p:sp>
+      <p:sp>
+        <p:nvSpPr>
+          <p:cNvPr id="13" name="Text 10"/>
           <p:cNvSpPr/>
           <p:nvPr/>
         </p:nvSpPr>
@@ -15129,7 +15215,7 @@
                 <a:ea typeface="Courier New" pitchFamily="34" charset="-122"/>
                 <a:cs typeface="Courier New" pitchFamily="34" charset="-120"/>
               </a:rPr>
-              <a:t>bench/headtohead/REPORT.md — versions pinned, binary sha256 recorded, frozen LocBench slice (dataset.lock)</a:t>
+              <a:t>bench/headtohead/r2-2026-08-03/ · r3-headroom-2026-08-03/ · docs/EVALS.md §2 — versions pinned, an adversarial VERIFIER.md ships with each round</a:t>
             </a:r>
             <a:endParaRPr lang="en-US" sz="1050" dirty="0"/>
           </a:p>

</xml_diff>

<commit_message>
docs(present): head-to-head slide carries both rounds as separate charts
Round 1's four-tool table (Aider repo-map, graphify, codebase-memory-mcp) returns to the
slide as its own chart under the round-2 chart — each round on its own axis with the
not-number-comparable rule printed in the round-1 label, honouring the provenance rule
while keeping the widely-known competitors visible. Wall-clock card gains round 1's cold
medians (Aider 2.5 s, graphify 5.8 s).

Co-Authored-By: Claude Fable 5 <noreply@anthropic.com>
</commit_message>
<xml_diff>
--- a/present/ripwire-showcase.pptx
+++ b/present/ripwire-showcase.pptx
@@ -164,7 +164,7 @@
               <a:lstStyle/>
               <a:p>
                 <a:pPr>
-                  <a:defRPr b="0" i="0" strike="noStrike" sz="1300" u="none">
+                  <a:defRPr b="0" i="0" strike="noStrike" sz="1100" u="none">
                     <a:solidFill>
                       <a:srgbClr val="E6EDF3"/>
                     </a:solidFill>
@@ -276,7 +276,7 @@
             <a:lstStyle/>
             <a:p>
               <a:pPr>
-                <a:defRPr b="0" i="0" strike="noStrike" sz="1300" u="none">
+                <a:defRPr b="0" i="0" strike="noStrike" sz="1100" u="none">
                   <a:solidFill>
                     <a:srgbClr val="E6EDF3"/>
                   </a:solidFill>
@@ -293,7 +293,7 @@
           <c:showBubbleSize val="0"/>
           <c:showLeaderLines val="0"/>
         </c:dLbls>
-        <c:gapWidth val="60"/>
+        <c:gapWidth val="50"/>
         <c:overlap val="0"/>
         <c:axId val="2094734554"/>
         <c:axId val="2094734552"/>
@@ -324,7 +324,7 @@
           <a:lstStyle/>
           <a:p>
             <a:pPr>
-              <a:defRPr sz="1250" b="0" i="0" u="none" strike="noStrike">
+              <a:defRPr sz="1050" b="0" i="0" u="none" strike="noStrike">
                 <a:solidFill>
                   <a:srgbClr val="E6EDF3"/>
                 </a:solidFill>
@@ -378,7 +378,7 @@
           <a:lstStyle/>
           <a:p>
             <a:pPr>
-              <a:defRPr sz="1000" b="0" i="0" u="none" strike="noStrike">
+              <a:defRPr sz="900" b="0" i="0" u="none" strike="noStrike">
                 <a:solidFill>
                   <a:srgbClr val="8B95A5"/>
                 </a:solidFill>
@@ -423,6 +423,304 @@
 </file>
 
 <file path=ppt/charts/chart2.xml><?xml version="1.0" encoding="utf-8"?>
+<c:chartSpace xmlns:c="http://schemas.openxmlformats.org/drawingml/2006/chart" xmlns:a="http://schemas.openxmlformats.org/drawingml/2006/main" xmlns:r="http://schemas.openxmlformats.org/officeDocument/2006/relationships">
+  <c:date1904 val="0"/>
+  <c:roundedCorners val="1"/>
+  <c:chart>
+    <c:autoTitleDeleted val="1"/>
+    <c:plotArea>
+      <c:layout/>
+      <c:barChart>
+        <c:barDir val="bar"/>
+        <c:grouping val="clustered"/>
+        <c:varyColors val="0"/>
+        <c:ser>
+          <c:idx val="0"/>
+          <c:order val="0"/>
+          <c:tx>
+            <c:strRef>
+              <c:f>Sheet1!$B$1</c:f>
+              <c:strCache>
+                <c:ptCount val="1"/>
+                <c:pt idx="0">
+                  <c:v>strict file@10</c:v>
+                </c:pt>
+              </c:strCache>
+            </c:strRef>
+          </c:tx>
+          <c:spPr>
+            <a:solidFill>
+              <a:srgbClr val="56D6E8"/>
+            </a:solidFill>
+            <a:effectLst/>
+          </c:spPr>
+          <c:invertIfNegative val="0"/>
+          <c:dLbls>
+            <c:numFmt formatCode="0.0" sourceLinked="0"/>
+            <c:txPr>
+              <a:bodyPr/>
+              <a:lstStyle/>
+              <a:p>
+                <a:pPr>
+                  <a:defRPr b="0" i="0" strike="noStrike" sz="1100" u="none">
+                    <a:solidFill>
+                      <a:srgbClr val="E6EDF3"/>
+                    </a:solidFill>
+                    <a:latin typeface="Arial"/>
+                  </a:defRPr>
+                </a:pPr>
+              </a:p>
+            </c:txPr>
+            <c:showLegendKey val="0"/>
+            <c:showVal val="1"/>
+            <c:showCatName val="0"/>
+            <c:showSerName val="0"/>
+            <c:showPercent val="0"/>
+            <c:showBubbleSize val="0"/>
+            <c:showLeaderLines val="0"/>
+          </c:dLbls>
+          <c:dPt>
+            <c:idx val="0"/>
+            <c:invertIfNegative val="0"/>
+            <c:bubble3D val="0"/>
+            <c:spPr>
+              <a:solidFill>
+                <a:srgbClr val="56D6E8"/>
+              </a:solidFill>
+              <a:effectLst/>
+            </c:spPr>
+          </c:dPt>
+          <c:dPt>
+            <c:idx val="1"/>
+            <c:invertIfNegative val="0"/>
+            <c:bubble3D val="0"/>
+            <c:spPr>
+              <a:solidFill>
+                <a:srgbClr val="3A4353"/>
+              </a:solidFill>
+              <a:effectLst/>
+            </c:spPr>
+          </c:dPt>
+          <c:dPt>
+            <c:idx val="2"/>
+            <c:invertIfNegative val="0"/>
+            <c:bubble3D val="0"/>
+            <c:spPr>
+              <a:solidFill>
+                <a:srgbClr val="3A4353"/>
+              </a:solidFill>
+              <a:effectLst/>
+            </c:spPr>
+          </c:dPt>
+          <c:dPt>
+            <c:idx val="3"/>
+            <c:invertIfNegative val="0"/>
+            <c:bubble3D val="0"/>
+            <c:spPr>
+              <a:solidFill>
+                <a:srgbClr val="3A4353"/>
+              </a:solidFill>
+              <a:effectLst/>
+            </c:spPr>
+          </c:dPt>
+          <c:cat>
+            <c:multiLvlStrRef>
+              <c:f>Sheet1!$A$2:$A$5</c:f>
+              <c:multiLvlStrCache>
+                <c:ptCount val="4"/>
+                <c:lvl>
+                  <c:pt idx="0">
+                    <c:v>ripwire --for</c:v>
+                  </c:pt>
+                  <c:pt idx="1">
+                    <c:v>codebase-memory-mcp</c:v>
+                  </c:pt>
+                  <c:pt idx="2">
+                    <c:v>graphify</c:v>
+                  </c:pt>
+                  <c:pt idx="3">
+                    <c:v>Aider repo-map</c:v>
+                  </c:pt>
+                </c:lvl>
+              </c:multiLvlStrCache>
+            </c:multiLvlStrRef>
+          </c:cat>
+          <c:val>
+            <c:numRef>
+              <c:f>Sheet1!$B$2:$B$5</c:f>
+              <c:numCache>
+                <c:formatCode>General</c:formatCode>
+                <c:ptCount val="4"/>
+                <c:pt idx="0">
+                  <c:v>36.7</c:v>
+                </c:pt>
+                <c:pt idx="1">
+                  <c:v>26.7</c:v>
+                </c:pt>
+                <c:pt idx="2">
+                  <c:v>21.7</c:v>
+                </c:pt>
+                <c:pt idx="3">
+                  <c:v>13.3</c:v>
+                </c:pt>
+              </c:numCache>
+            </c:numRef>
+          </c:val>
+        </c:ser>
+        <c:dLbls>
+          <c:numFmt formatCode="0.0" sourceLinked="0"/>
+          <c:txPr>
+            <a:bodyPr/>
+            <a:lstStyle/>
+            <a:p>
+              <a:pPr>
+                <a:defRPr b="0" i="0" strike="noStrike" sz="1100" u="none">
+                  <a:solidFill>
+                    <a:srgbClr val="E6EDF3"/>
+                  </a:solidFill>
+                  <a:latin typeface="Arial"/>
+                </a:defRPr>
+              </a:pPr>
+            </a:p>
+          </c:txPr>
+          <c:showLegendKey val="0"/>
+          <c:showVal val="1"/>
+          <c:showCatName val="0"/>
+          <c:showSerName val="0"/>
+          <c:showPercent val="0"/>
+          <c:showBubbleSize val="0"/>
+          <c:showLeaderLines val="0"/>
+        </c:dLbls>
+        <c:gapWidth val="50"/>
+        <c:overlap val="0"/>
+        <c:axId val="2094734554"/>
+        <c:axId val="2094734552"/>
+        <c:axId val="2094734556"/>
+      </c:barChart>
+      <c:catAx>
+        <c:axId val="2094734554"/>
+        <c:scaling>
+          <c:orientation val="minMax"/>
+        </c:scaling>
+        <c:delete val="0"/>
+        <c:axPos val="l"/>
+        <c:numFmt formatCode="General" sourceLinked="1"/>
+        <c:majorTickMark val="out"/>
+        <c:minorTickMark val="none"/>
+        <c:tickLblPos val="nextTo"/>
+        <c:spPr>
+          <a:ln w="12700" cap="flat">
+            <a:solidFill>
+              <a:srgbClr val="888888"/>
+            </a:solidFill>
+            <a:prstDash val="solid"/>
+            <a:round/>
+          </a:ln>
+        </c:spPr>
+        <c:txPr>
+          <a:bodyPr/>
+          <a:lstStyle/>
+          <a:p>
+            <a:pPr>
+              <a:defRPr sz="1050" b="0" i="0" u="none" strike="noStrike">
+                <a:solidFill>
+                  <a:srgbClr val="E6EDF3"/>
+                </a:solidFill>
+                <a:latin typeface="Arial"/>
+              </a:defRPr>
+            </a:pPr>
+            <a:endParaRPr lang="en-US"/>
+          </a:p>
+        </c:txPr>
+        <c:crossAx val="2094734552"/>
+        <c:crosses val="autoZero"/>
+        <c:auto val="1"/>
+        <c:lblAlgn val="ctr"/>
+        <c:noMultiLvlLbl val="1"/>
+      </c:catAx>
+      <c:valAx>
+        <c:axId val="2094734552"/>
+        <c:scaling>
+          <c:orientation val="minMax"/>
+          <c:max val="45"/>
+          <c:min val="0"/>
+        </c:scaling>
+        <c:delete val="0"/>
+        <c:axPos val="b"/>
+        <c:majorGridlines>
+          <c:spPr>
+            <a:ln w="6350" cap="flat">
+              <a:solidFill>
+                <a:srgbClr val="232D3D"/>
+              </a:solidFill>
+              <a:prstDash val="solid"/>
+              <a:round/>
+            </a:ln>
+          </c:spPr>
+        </c:majorGridlines>
+        <c:numFmt formatCode="General" sourceLinked="0"/>
+        <c:majorTickMark val="out"/>
+        <c:minorTickMark val="none"/>
+        <c:tickLblPos val="low"/>
+        <c:spPr>
+          <a:ln w="12700" cap="flat">
+            <a:solidFill>
+              <a:srgbClr val="888888"/>
+            </a:solidFill>
+            <a:prstDash val="solid"/>
+            <a:round/>
+          </a:ln>
+        </c:spPr>
+        <c:txPr>
+          <a:bodyPr/>
+          <a:lstStyle/>
+          <a:p>
+            <a:pPr>
+              <a:defRPr sz="900" b="0" i="0" u="none" strike="noStrike">
+                <a:solidFill>
+                  <a:srgbClr val="8B95A5"/>
+                </a:solidFill>
+                <a:latin typeface="Arial"/>
+              </a:defRPr>
+            </a:pPr>
+            <a:endParaRPr lang="en-US"/>
+          </a:p>
+        </c:txPr>
+        <c:crossAx val="2094734554"/>
+        <c:crosses val="autoZero"/>
+        <c:crossBetween val="between"/>
+      </c:valAx>
+      <c:spPr>
+        <a:solidFill>
+          <a:srgbClr val="0D1117"/>
+        </a:solidFill>
+        <a:ln>
+          <a:noFill/>
+        </a:ln>
+        <a:effectLst/>
+      </c:spPr>
+    </c:plotArea>
+    <c:plotVisOnly val="1"/>
+    <c:dispBlanksAs val="span"/>
+  </c:chart>
+  <c:spPr>
+    <a:solidFill>
+      <a:srgbClr val="0D1117"/>
+    </a:solidFill>
+    <a:ln w="12700" cap="flat">
+      <a:solidFill>
+        <a:srgbClr val="0D1117"/>
+      </a:solidFill>
+    </a:ln>
+    <a:effectLst/>
+  </c:spPr>
+  <c:externalData r:id="rId1">
+    <c:autoUpdate val="0"/>
+  </c:externalData>
+</c:chartSpace>
+</file>
+
+<file path=ppt/charts/chart3.xml><?xml version="1.0" encoding="utf-8"?>
 <c:chartSpace xmlns:c="http://schemas.openxmlformats.org/drawingml/2006/chart" xmlns:a="http://schemas.openxmlformats.org/drawingml/2006/main" xmlns:r="http://schemas.openxmlformats.org/officeDocument/2006/relationships">
   <c:date1904 val="0"/>
   <c:roundedCorners val="1"/>
@@ -686,7 +984,7 @@
 </c:chartSpace>
 </file>
 
-<file path=ppt/charts/chart3.xml><?xml version="1.0" encoding="utf-8"?>
+<file path=ppt/charts/chart4.xml><?xml version="1.0" encoding="utf-8"?>
 <c:chartSpace xmlns:c="http://schemas.openxmlformats.org/drawingml/2006/chart" xmlns:a="http://schemas.openxmlformats.org/drawingml/2006/main" xmlns:r="http://schemas.openxmlformats.org/officeDocument/2006/relationships">
   <c:date1904 val="0"/>
   <c:roundedCorners val="1"/>
@@ -1001,7 +1299,7 @@
 </c:chartSpace>
 </file>
 
-<file path=ppt/charts/chart4.xml><?xml version="1.0" encoding="utf-8"?>
+<file path=ppt/charts/chart5.xml><?xml version="1.0" encoding="utf-8"?>
 <c:chartSpace xmlns:c="http://schemas.openxmlformats.org/drawingml/2006/chart" xmlns:a="http://schemas.openxmlformats.org/drawingml/2006/main" xmlns:r="http://schemas.openxmlformats.org/officeDocument/2006/relationships">
   <c:date1904 val="0"/>
   <c:roundedCorners val="1"/>
@@ -14824,21 +15122,60 @@
                 <a:ea typeface="Arial" pitchFamily="34" charset="-122"/>
                 <a:cs typeface="Arial" pitchFamily="34" charset="-120"/>
               </a:rPr>
-              <a:t>Head-to-head: strict localization, latest round</a:t>
+              <a:t>Head-to-head: every round, every tool</a:t>
             </a:r>
             <a:endParaRPr lang="en-US" sz="3400" dirty="0"/>
+          </a:p>
+        </p:txBody>
+      </p:sp>
+      <p:sp>
+        <p:nvSpPr>
+          <p:cNvPr id="4" name="Text 2"/>
+          <p:cNvSpPr/>
+          <p:nvPr/>
+        </p:nvSpPr>
+        <p:spPr>
+          <a:xfrm>
+            <a:off x="566928" y="1664208"/>
+            <a:ext cx="6675120" cy="256032"/>
+          </a:xfrm>
+          <a:prstGeom prst="rect">
+            <a:avLst/>
+          </a:prstGeom>
+          <a:noFill/>
+          <a:ln/>
+        </p:spPr>
+        <p:txBody>
+          <a:bodyPr wrap="square" lIns="0" tIns="0" rIns="0" bIns="0" rtlCol="0" anchor="ctr"/>
+          <a:lstStyle/>
+          <a:p>
+            <a:pPr indent="0" marL="0">
+              <a:buNone/>
+            </a:pPr>
+            <a:r>
+              <a:rPr lang="en-US" sz="1150" b="1" dirty="0">
+                <a:solidFill>
+                  <a:srgbClr val="E6EDF3"/>
+                </a:solidFill>
+                <a:latin typeface="Arial" pitchFamily="34" charset="0"/>
+                <a:ea typeface="Arial" pitchFamily="34" charset="-122"/>
+                <a:cs typeface="Arial" pitchFamily="34" charset="-120"/>
+              </a:rPr>
+              <a:t>Round 2 (2026-08-03) — strict file@10, N = 60</a:t>
+            </a:r>
+            <a:endParaRPr lang="en-US" sz="1150" dirty="0"/>
           </a:p>
         </p:txBody>
       </p:sp>
       <p:graphicFrame>
         <p:nvGraphicFramePr>
-          <p:cNvPr id="4" name="Chart 0" descr=""/>
+          <p:cNvPr id="5" name="Chart 0" descr=""/>
           <p:cNvGraphicFramePr/>
           <p:nvPr/>
         </p:nvGraphicFramePr>
         <p:xfrm>
-          <a:off x="566928" y="1783080"/>
-          <a:ext cx="6675120" cy="3566160"/>
+          <a:off x="566928" y="1938528"/>
+          <a:ext cx="6675120" cy="2057400"/>
         </p:xfrm>
         <a:graphic xmlns:a="http://schemas.openxmlformats.org/drawingml/2006/main">
           <a:graphicData uri="http://schemas.openxmlformats.org/drawingml/2006/chart">
@@ -14848,46 +15185,62 @@
       </p:graphicFrame>
       <p:sp>
         <p:nvSpPr>
-          <p:cNvPr id="5" name="Text 2"/>
-          <p:cNvSpPr/>
-          <p:nvPr/>
-        </p:nvSpPr>
-        <p:spPr>
-          <a:xfrm>
-            <a:off x="566928" y="5440680"/>
-            <a:ext cx="6675120" cy="777240"/>
-          </a:xfrm>
-          <a:prstGeom prst="rect">
-            <a:avLst/>
-          </a:prstGeom>
-          <a:noFill/>
-          <a:ln/>
-        </p:spPr>
-        <p:txBody>
-          <a:bodyPr wrap="square" lIns="0" tIns="0" rIns="0" bIns="0" rtlCol="0" anchor="ctr"/>
-          <a:lstStyle/>
-          <a:p>
-            <a:pPr indent="0" marL="0">
-              <a:buNone/>
-            </a:pPr>
-            <a:r>
-              <a:rPr lang="en-US" sz="1050" dirty="0">
-                <a:solidFill>
-                  <a:srgbClr val="8B95A5"/>
-                </a:solidFill>
-                <a:latin typeface="Arial" pitchFamily="34" charset="0"/>
-                <a:ea typeface="Arial" pitchFamily="34" charset="-122"/>
-                <a:cs typeface="Arial" pitchFamily="34" charset="-120"/>
-              </a:rPr>
-              <a:t>codeseek's keyless raw-text arm scored 0.0% (0 results on 60/60) — a query-protocol boundary, not its embedder mode. Vexp and CodeIndexer were excluded by free-tier caps, not beaten; the report records the exact limits.</a:t>
-            </a:r>
-            <a:endParaRPr lang="en-US" sz="1050" dirty="0"/>
-          </a:p>
-        </p:txBody>
-      </p:sp>
-      <p:sp>
-        <p:nvSpPr>
-          <p:cNvPr id="6" name="Shape 3"/>
+          <p:cNvPr id="6" name="Text 3"/>
+          <p:cNvSpPr/>
+          <p:nvPr/>
+        </p:nvSpPr>
+        <p:spPr>
+          <a:xfrm>
+            <a:off x="566928" y="4114800"/>
+            <a:ext cx="6675120" cy="256032"/>
+          </a:xfrm>
+          <a:prstGeom prst="rect">
+            <a:avLst/>
+          </a:prstGeom>
+          <a:noFill/>
+          <a:ln/>
+        </p:spPr>
+        <p:txBody>
+          <a:bodyPr wrap="square" lIns="0" tIns="0" rIns="0" bIns="0" rtlCol="0" anchor="ctr"/>
+          <a:lstStyle/>
+          <a:p>
+            <a:pPr indent="0" marL="0">
+              <a:buNone/>
+            </a:pPr>
+            <a:r>
+              <a:rPr lang="en-US" sz="1150" b="1" dirty="0">
+                <a:solidFill>
+                  <a:srgbClr val="E6EDF3"/>
+                </a:solidFill>
+                <a:latin typeface="Arial" pitchFamily="34" charset="0"/>
+                <a:ea typeface="Arial" pitchFamily="34" charset="-122"/>
+                <a:cs typeface="Arial" pitchFamily="34" charset="-120"/>
+              </a:rPr>
+              <a:t>Round 1 — strict file@10, N = 60 (own binary + evaluator; rounds are not number-comparable)</a:t>
+            </a:r>
+            <a:endParaRPr lang="en-US" sz="1150" dirty="0"/>
+          </a:p>
+        </p:txBody>
+      </p:sp>
+      <p:graphicFrame>
+        <p:nvGraphicFramePr>
+          <p:cNvPr id="7" name="Chart 1" descr=""/>
+          <p:cNvGraphicFramePr/>
+          <p:nvPr/>
+        </p:nvGraphicFramePr>
+        <p:xfrm>
+          <a:off x="566928" y="4389120"/>
+          <a:ext cx="6675120" cy="2057400"/>
+        </p:xfrm>
+        <a:graphic xmlns:a="http://schemas.openxmlformats.org/drawingml/2006/main">
+          <a:graphicData uri="http://schemas.openxmlformats.org/drawingml/2006/chart">
+            <c:chart xmlns:c="http://schemas.openxmlformats.org/drawingml/2006/chart" r:id="rId2"/>
+          </a:graphicData>
+        </a:graphic>
+      </p:graphicFrame>
+      <p:sp>
+        <p:nvSpPr>
+          <p:cNvPr id="8" name="Shape 4"/>
           <p:cNvSpPr/>
           <p:nvPr/>
         </p:nvSpPr>
@@ -14914,7 +15267,7 @@
       </p:sp>
       <p:sp>
         <p:nvSpPr>
-          <p:cNvPr id="7" name="Text 4"/>
+          <p:cNvPr id="9" name="Text 5"/>
           <p:cNvSpPr/>
           <p:nvPr/>
         </p:nvSpPr>
@@ -14953,7 +15306,7 @@
       </p:sp>
       <p:sp>
         <p:nvSpPr>
-          <p:cNvPr id="8" name="Text 5"/>
+          <p:cNvPr id="10" name="Text 6"/>
           <p:cNvSpPr/>
           <p:nvPr/>
         </p:nvSpPr>
@@ -15009,18 +15362,18 @@
       </p:sp>
       <p:sp>
         <p:nvSpPr>
-          <p:cNvPr id="9" name="Shape 6"/>
-          <p:cNvSpPr/>
-          <p:nvPr/>
-        </p:nvSpPr>
-        <p:spPr>
-          <a:xfrm>
-            <a:off x="7498080" y="3474720"/>
-            <a:ext cx="4023360" cy="1371600"/>
+          <p:cNvPr id="11" name="Shape 7"/>
+          <p:cNvSpPr/>
+          <p:nvPr/>
+        </p:nvSpPr>
+        <p:spPr>
+          <a:xfrm>
+            <a:off x="7498080" y="3429000"/>
+            <a:ext cx="4023360" cy="1554480"/>
           </a:xfrm>
           <a:prstGeom prst="roundRect">
             <a:avLst>
-              <a:gd name="adj" fmla="val 6000"/>
+              <a:gd name="adj" fmla="val 5294"/>
             </a:avLst>
           </a:prstGeom>
           <a:solidFill>
@@ -15036,30 +15389,30 @@
       </p:sp>
       <p:sp>
         <p:nvSpPr>
-          <p:cNvPr id="10" name="Text 7"/>
-          <p:cNvSpPr/>
-          <p:nvPr/>
-        </p:nvSpPr>
-        <p:spPr>
-          <a:xfrm>
-            <a:off x="7680960" y="3593592"/>
-            <a:ext cx="3703320" cy="1188720"/>
-          </a:xfrm>
-          <a:prstGeom prst="rect">
-            <a:avLst/>
-          </a:prstGeom>
-          <a:noFill/>
-          <a:ln/>
-        </p:spPr>
-        <p:txBody>
-          <a:bodyPr wrap="square" lIns="0" tIns="0" rIns="0" bIns="0" rtlCol="0" anchor="ctr"/>
-          <a:lstStyle/>
-          <a:p>
-            <a:pPr indent="0" marL="0">
-              <a:buNone/>
-            </a:pPr>
-            <a:r>
-              <a:rPr lang="en-US" sz="1050" b="1" dirty="0">
+          <p:cNvPr id="12" name="Text 8"/>
+          <p:cNvSpPr/>
+          <p:nvPr/>
+        </p:nvSpPr>
+        <p:spPr>
+          <a:xfrm>
+            <a:off x="7680960" y="3547872"/>
+            <a:ext cx="3703320" cy="1371600"/>
+          </a:xfrm>
+          <a:prstGeom prst="rect">
+            <a:avLst/>
+          </a:prstGeom>
+          <a:noFill/>
+          <a:ln/>
+        </p:spPr>
+        <p:txBody>
+          <a:bodyPr wrap="square" lIns="0" tIns="0" rIns="0" bIns="0" rtlCol="0" anchor="ctr"/>
+          <a:lstStyle/>
+          <a:p>
+            <a:pPr indent="0" marL="0">
+              <a:buNone/>
+            </a:pPr>
+            <a:r>
+              <a:rPr lang="en-US" sz="1000" b="1" dirty="0">
                 <a:solidFill>
                   <a:srgbClr val="E6EDF3"/>
                 </a:solidFill>
@@ -15073,7 +15426,7 @@
               <a:buNone/>
             </a:pPr>
             <a:r>
-              <a:rPr lang="en-US" sz="1050" dirty="0">
+              <a:rPr lang="en-US" sz="1000" dirty="0">
                 <a:solidFill>
                   <a:srgbClr val="8B95A5"/>
                 </a:solidFill>
@@ -15081,14 +15434,14 @@
                 <a:ea typeface="Arial" pitchFamily="34" charset="-122"/>
                 <a:cs typeface="Arial" pitchFamily="34" charset="-120"/>
               </a:rPr>
-              <a:t>ripwire 0.114 s · repowise 1.14 s (incl. a fresh MCP-server spawn per query).
+              <a:t>ripwire 0.114 s · repowise 1.14 s (incl. a per-query server spawn) — round 1: Aider 2.5 s · graphify 5.8 s, cold per run.
 </a:t>
             </a:r>
             <a:pPr indent="0" marL="0">
               <a:buNone/>
             </a:pPr>
             <a:r>
-              <a:rPr lang="en-US" sz="1050" dirty="0">
+              <a:rPr lang="en-US" sz="1000" dirty="0">
                 <a:solidFill>
                   <a:srgbClr val="8B95A5"/>
                 </a:solidFill>
@@ -15096,26 +15449,26 @@
                 <a:ea typeface="Arial" pitchFamily="34" charset="-122"/>
                 <a:cs typeface="Arial" pitchFamily="34" charset="-120"/>
               </a:rPr>
-              <a:t>Round 1, four tools: 36.7% vs cmm 26.7 · graphify 21.7 · Aider 13.3 — each round is internally paired; rounds are not number-comparable.</a:t>
-            </a:r>
-            <a:endParaRPr lang="en-US" sz="1050" dirty="0"/>
-          </a:p>
-        </p:txBody>
-      </p:sp>
-      <p:sp>
-        <p:nvSpPr>
-          <p:cNvPr id="11" name="Shape 8"/>
-          <p:cNvSpPr/>
-          <p:nvPr/>
-        </p:nvSpPr>
-        <p:spPr>
-          <a:xfrm>
-            <a:off x="7498080" y="4983480"/>
-            <a:ext cx="4023360" cy="1051560"/>
+              <a:t>codeseek's raw arm: 0 results on 60/60 — a query-protocol boundary, not its embedder mode. Vexp and CodeIndexer were excluded by free-tier caps, not beaten.</a:t>
+            </a:r>
+            <a:endParaRPr lang="en-US" sz="1000" dirty="0"/>
+          </a:p>
+        </p:txBody>
+      </p:sp>
+      <p:sp>
+        <p:nvSpPr>
+          <p:cNvPr id="13" name="Shape 9"/>
+          <p:cNvSpPr/>
+          <p:nvPr/>
+        </p:nvSpPr>
+        <p:spPr>
+          <a:xfrm>
+            <a:off x="7498080" y="5120640"/>
+            <a:ext cx="4023360" cy="1005840"/>
           </a:xfrm>
           <a:prstGeom prst="roundRect">
             <a:avLst>
-              <a:gd name="adj" fmla="val 7826"/>
+              <a:gd name="adj" fmla="val 8182"/>
             </a:avLst>
           </a:prstGeom>
           <a:solidFill>
@@ -15131,30 +15484,30 @@
       </p:sp>
       <p:sp>
         <p:nvSpPr>
-          <p:cNvPr id="12" name="Text 9"/>
-          <p:cNvSpPr/>
-          <p:nvPr/>
-        </p:nvSpPr>
-        <p:spPr>
-          <a:xfrm>
-            <a:off x="7680960" y="5084064"/>
-            <a:ext cx="3703320" cy="896112"/>
-          </a:xfrm>
-          <a:prstGeom prst="rect">
-            <a:avLst/>
-          </a:prstGeom>
-          <a:noFill/>
-          <a:ln/>
-        </p:spPr>
-        <p:txBody>
-          <a:bodyPr wrap="square" lIns="0" tIns="0" rIns="0" bIns="0" rtlCol="0" anchor="ctr"/>
-          <a:lstStyle/>
-          <a:p>
-            <a:pPr indent="0" marL="0">
-              <a:buNone/>
-            </a:pPr>
-            <a:r>
-              <a:rPr lang="en-US" sz="1050" b="1" dirty="0">
+          <p:cNvPr id="14" name="Text 10"/>
+          <p:cNvSpPr/>
+          <p:nvPr/>
+        </p:nvSpPr>
+        <p:spPr>
+          <a:xfrm>
+            <a:off x="7680960" y="5221224"/>
+            <a:ext cx="3703320" cy="841248"/>
+          </a:xfrm>
+          <a:prstGeom prst="rect">
+            <a:avLst/>
+          </a:prstGeom>
+          <a:noFill/>
+          <a:ln/>
+        </p:spPr>
+        <p:txBody>
+          <a:bodyPr wrap="square" lIns="0" tIns="0" rIns="0" bIns="0" rtlCol="0" anchor="ctr"/>
+          <a:lstStyle/>
+          <a:p>
+            <a:pPr indent="0" marL="0">
+              <a:buNone/>
+            </a:pPr>
+            <a:r>
+              <a:rPr lang="en-US" sz="1000" b="1" dirty="0">
                 <a:solidFill>
                   <a:srgbClr val="E6EDF3"/>
                 </a:solidFill>
@@ -15168,7 +15521,7 @@
               <a:buNone/>
             </a:pPr>
             <a:r>
-              <a:rPr lang="en-US" sz="1050" dirty="0">
+              <a:rPr lang="en-US" sz="1000" dirty="0">
                 <a:solidFill>
                   <a:srgbClr val="8B95A5"/>
                 </a:solidFill>
@@ -15176,15 +15529,15 @@
                 <a:ea typeface="Arial" pitchFamily="34" charset="-122"/>
                 <a:cs typeface="Arial" pitchFamily="34" charset="-120"/>
               </a:rPr>
-              <a:t>headroom (the compression layer) passed code through byte-identical; ripwire answered at 7.3% of the naive baseline's tokens. Its own losses ship first in that report.</a:t>
-            </a:r>
-            <a:endParaRPr lang="en-US" sz="1050" dirty="0"/>
-          </a:p>
-        </p:txBody>
-      </p:sp>
-      <p:sp>
-        <p:nvSpPr>
-          <p:cNvPr id="13" name="Text 10"/>
+              <a:t>headroom (the compression layer) passed code through byte-identical; ripwire answered at 7.3% of the naive baseline's tokens.</a:t>
+            </a:r>
+            <a:endParaRPr lang="en-US" sz="1000" dirty="0"/>
+          </a:p>
+        </p:txBody>
+      </p:sp>
+      <p:sp>
+        <p:nvSpPr>
+          <p:cNvPr id="15" name="Text 11"/>
           <p:cNvSpPr/>
           <p:nvPr/>
         </p:nvSpPr>
@@ -15215,7 +15568,7 @@
                 <a:ea typeface="Courier New" pitchFamily="34" charset="-122"/>
                 <a:cs typeface="Courier New" pitchFamily="34" charset="-120"/>
               </a:rPr>
-              <a:t>bench/headtohead/r2-2026-08-03/ · r3-headroom-2026-08-03/ · docs/EVALS.md §2 — versions pinned, an adversarial VERIFIER.md ships with each round</a:t>
+              <a:t>bench/headtohead/REPORT.md (r1) · r2-2026-08-03/ · r3-headroom-2026-08-03/ · docs/EVALS.md §2 — an adversarial VERIFIER.md ships with each round</a:t>
             </a:r>
             <a:endParaRPr lang="en-US" sz="1050" dirty="0"/>
           </a:p>

</xml_diff>

<commit_message>
feat: harden audit and Codex CLI workflow
</commit_message>
<xml_diff>
--- a/present/ripwire-showcase.pptx
+++ b/present/ripwire-showcase.pptx
@@ -7070,7 +7070,7 @@
                 <a:ea typeface="Arial" pitchFamily="34" charset="-122"/>
                 <a:cs typeface="Arial" pitchFamily="34" charset="-120"/>
               </a:rPr>
-              <a:t>315 gate scripts</a:t>
+              <a:t>334 gate scripts</a:t>
             </a:r>
             <a:endParaRPr lang="en-US" sz="1450" dirty="0"/>
           </a:p>
@@ -8305,7 +8305,7 @@
               <a:buNone/>
             </a:pPr>
             <a:r>
-              <a:rPr lang="en-US" sz="3400" b="1" dirty="0">
+              <a:rPr lang="en-US" sz="3000" b="1" dirty="0">
                 <a:solidFill>
                   <a:srgbClr val="E6EDF3"/>
                 </a:solidFill>
@@ -8313,9 +8313,9 @@
                 <a:ea typeface="Arial" pitchFamily="34" charset="-122"/>
                 <a:cs typeface="Arial" pitchFamily="34" charset="-120"/>
               </a:rPr>
-              <a:t>Wire it into your agent in one command</a:t>
-            </a:r>
-            <a:endParaRPr lang="en-US" sz="3400" dirty="0"/>
+              <a:t>Wire it into Codex in one command</a:t>
+            </a:r>
+            <a:endParaRPr lang="en-US" sz="3000" dirty="0"/>
           </a:p>
         </p:txBody>
       </p:sp>
@@ -8328,7 +8328,7 @@
         <p:spPr>
           <a:xfrm>
             <a:off x="566928" y="1828800"/>
-            <a:ext cx="4206240" cy="502920"/>
+            <a:ext cx="6217920" cy="502920"/>
           </a:xfrm>
           <a:prstGeom prst="roundRect">
             <a:avLst>
@@ -8355,7 +8355,7 @@
         <p:spPr>
           <a:xfrm>
             <a:off x="621792" y="1828800"/>
-            <a:ext cx="4096512" cy="502920"/>
+            <a:ext cx="6108192" cy="502920"/>
           </a:xfrm>
           <a:prstGeom prst="rect">
             <a:avLst/>
@@ -8371,7 +8371,7 @@
               <a:buNone/>
             </a:pPr>
             <a:r>
-              <a:rPr lang="en-US" sz="1500" dirty="0">
+              <a:rPr lang="en-US" sz="1350" dirty="0">
                 <a:solidFill>
                   <a:srgbClr val="4AC26B"/>
                 </a:solidFill>
@@ -8379,9 +8379,9 @@
                 <a:ea typeface="Courier New" pitchFamily="34" charset="-122"/>
                 <a:cs typeface="Courier New" pitchFamily="34" charset="-120"/>
               </a:rPr>
-              <a:t>$ ripwire wrap claude</a:t>
-            </a:r>
-            <a:endParaRPr lang="en-US" sz="1500" dirty="0"/>
+              <a:t>$ codex mcp add ripwire -- ripwire --mcp</a:t>
+            </a:r>
+            <a:endParaRPr lang="en-US" sz="1350" dirty="0"/>
           </a:p>
         </p:txBody>
       </p:sp>
@@ -8393,8 +8393,8 @@
         </p:nvSpPr>
         <p:spPr>
           <a:xfrm>
-            <a:off x="4937760" y="1828800"/>
-            <a:ext cx="5943600" cy="502920"/>
+            <a:off x="7040880" y="1828800"/>
+            <a:ext cx="4480560" cy="502920"/>
           </a:xfrm>
           <a:prstGeom prst="rect">
             <a:avLst/>
@@ -8418,7 +8418,7 @@
                 <a:ea typeface="Arial" pitchFamily="34" charset="-122"/>
                 <a:cs typeface="Arial" pitchFamily="34" charset="-120"/>
               </a:rPr>
-              <a:t>(also: cursor, codex, windsurf, gemini, aider)</a:t>
+              <a:t>plugin bundle also ships all 17 skills</a:t>
             </a:r>
             <a:endParaRPr lang="en-US" sz="1200" dirty="0"/>
           </a:p>
@@ -8733,7 +8733,7 @@
                 <a:ea typeface="Arial" pitchFamily="34" charset="-122"/>
                 <a:cs typeface="Arial" pitchFamily="34" charset="-120"/>
               </a:rPr>
-              <a:t>moment-matched skill files (orient, navigate, change-check, quality-bar …) installed by skills/install.sh</a:t>
+              <a:t>moment-matched workflows (orient, navigate, change-check, quality-bar …), bundled in the Codex plugin or installed by skills/install.sh</a:t>
             </a:r>
             <a:endParaRPr lang="en-US" sz="1150" dirty="0"/>
           </a:p>
@@ -12593,7 +12593,7 @@
                 <a:ea typeface="Arial" pitchFamily="34" charset="-122"/>
                 <a:cs typeface="Arial" pitchFamily="34" charset="-120"/>
               </a:rPr>
-              <a:t>an MCP server and 123 long flags behind one `--help` that is always the authority</a:t>
+              <a:t>an MCP server and 124 long flags behind one `--help` that is always the authority</a:t>
             </a:r>
             <a:endParaRPr lang="en-US" sz="1250" dirty="0"/>
           </a:p>
@@ -13750,7 +13750,7 @@
                 <a:ea typeface="Courier New" pitchFamily="34" charset="-122"/>
                 <a:cs typeface="Courier New" pitchFamily="34" charset="-120"/>
               </a:rPr>
-              <a:t>ripwire --help is generated from the binary's own flag table — 123 long flags; docs/COMMANDS.md documents 101 of them with real recorded output</a:t>
+              <a:t>ripwire --help is generated from the binary's own flag table — 124 long flags; docs/COMMANDS.md documents 101 of them with real recorded output</a:t>
             </a:r>
             <a:endParaRPr lang="en-US" sz="1050" dirty="0"/>
           </a:p>

</xml_diff>

<commit_message>
present: the narrow table band is a row() parameter, not a second copy of row()
--quality-delta flagged the new nrow helper as a 154-token duplication of the shared
row() it was copied from, and it was right. row() gains an optional width instead; the
one thing that actually differed becomes one parameter, and the r10 slide's local nrow
is a two-line adapter over it.

Co-Authored-By: Claude Fable 5 <noreply@anthropic.com>
</commit_message>
<xml_diff>
--- a/present/ripwire-showcase.pptx
+++ b/present/ripwire-showcase.pptx
@@ -28581,7 +28581,7 @@
         </p:nvSpPr>
         <p:spPr>
           <a:xfrm>
-            <a:off x="713232" y="1545336"/>
+            <a:off x="731520" y="1545336"/>
             <a:ext cx="2240280" cy="256032"/>
           </a:xfrm>
           <a:prstGeom prst="rect">
@@ -28620,7 +28620,7 @@
         </p:nvSpPr>
         <p:spPr>
           <a:xfrm>
-            <a:off x="3044952" y="1545336"/>
+            <a:off x="3081528" y="1545336"/>
             <a:ext cx="411480" cy="256032"/>
           </a:xfrm>
           <a:prstGeom prst="rect">
@@ -28659,7 +28659,7 @@
         </p:nvSpPr>
         <p:spPr>
           <a:xfrm>
-            <a:off x="3547872" y="1545336"/>
+            <a:off x="3602736" y="1545336"/>
             <a:ext cx="777240" cy="256032"/>
           </a:xfrm>
           <a:prstGeom prst="rect">
@@ -28698,7 +28698,7 @@
         </p:nvSpPr>
         <p:spPr>
           <a:xfrm>
-            <a:off x="4416552" y="1545336"/>
+            <a:off x="4489704" y="1545336"/>
             <a:ext cx="822960" cy="256032"/>
           </a:xfrm>
           <a:prstGeom prst="rect">
@@ -28737,7 +28737,7 @@
         </p:nvSpPr>
         <p:spPr>
           <a:xfrm>
-            <a:off x="5330952" y="1545336"/>
+            <a:off x="5422392" y="1545336"/>
             <a:ext cx="502920" cy="256032"/>
           </a:xfrm>
           <a:prstGeom prst="rect">
@@ -28776,7 +28776,7 @@
         </p:nvSpPr>
         <p:spPr>
           <a:xfrm>
-            <a:off x="5925312" y="1545336"/>
+            <a:off x="6035040" y="1545336"/>
             <a:ext cx="1325880" cy="256032"/>
           </a:xfrm>
           <a:prstGeom prst="rect">
@@ -28842,7 +28842,7 @@
         </p:nvSpPr>
         <p:spPr>
           <a:xfrm>
-            <a:off x="713232" y="1892808"/>
+            <a:off x="731520" y="1892808"/>
             <a:ext cx="2240280" cy="329184"/>
           </a:xfrm>
           <a:prstGeom prst="rect">
@@ -28881,7 +28881,7 @@
         </p:nvSpPr>
         <p:spPr>
           <a:xfrm>
-            <a:off x="3044952" y="1892808"/>
+            <a:off x="3081528" y="1892808"/>
             <a:ext cx="411480" cy="329184"/>
           </a:xfrm>
           <a:prstGeom prst="rect">
@@ -28920,7 +28920,7 @@
         </p:nvSpPr>
         <p:spPr>
           <a:xfrm>
-            <a:off x="3547872" y="1892808"/>
+            <a:off x="3602736" y="1892808"/>
             <a:ext cx="777240" cy="329184"/>
           </a:xfrm>
           <a:prstGeom prst="rect">
@@ -28959,7 +28959,7 @@
         </p:nvSpPr>
         <p:spPr>
           <a:xfrm>
-            <a:off x="4416552" y="1892808"/>
+            <a:off x="4489704" y="1892808"/>
             <a:ext cx="822960" cy="329184"/>
           </a:xfrm>
           <a:prstGeom prst="rect">
@@ -28998,7 +28998,7 @@
         </p:nvSpPr>
         <p:spPr>
           <a:xfrm>
-            <a:off x="5330952" y="1892808"/>
+            <a:off x="5422392" y="1892808"/>
             <a:ext cx="502920" cy="329184"/>
           </a:xfrm>
           <a:prstGeom prst="rect">
@@ -29037,7 +29037,7 @@
         </p:nvSpPr>
         <p:spPr>
           <a:xfrm>
-            <a:off x="5925312" y="1892808"/>
+            <a:off x="6035040" y="1892808"/>
             <a:ext cx="1325880" cy="329184"/>
           </a:xfrm>
           <a:prstGeom prst="rect">
@@ -29103,7 +29103,7 @@
         </p:nvSpPr>
         <p:spPr>
           <a:xfrm>
-            <a:off x="713232" y="2322576"/>
+            <a:off x="731520" y="2322576"/>
             <a:ext cx="2240280" cy="329184"/>
           </a:xfrm>
           <a:prstGeom prst="rect">
@@ -29142,7 +29142,7 @@
         </p:nvSpPr>
         <p:spPr>
           <a:xfrm>
-            <a:off x="3044952" y="2322576"/>
+            <a:off x="3081528" y="2322576"/>
             <a:ext cx="411480" cy="329184"/>
           </a:xfrm>
           <a:prstGeom prst="rect">
@@ -29181,7 +29181,7 @@
         </p:nvSpPr>
         <p:spPr>
           <a:xfrm>
-            <a:off x="3547872" y="2322576"/>
+            <a:off x="3602736" y="2322576"/>
             <a:ext cx="777240" cy="329184"/>
           </a:xfrm>
           <a:prstGeom prst="rect">
@@ -29220,7 +29220,7 @@
         </p:nvSpPr>
         <p:spPr>
           <a:xfrm>
-            <a:off x="4416552" y="2322576"/>
+            <a:off x="4489704" y="2322576"/>
             <a:ext cx="822960" cy="329184"/>
           </a:xfrm>
           <a:prstGeom prst="rect">
@@ -29259,7 +29259,7 @@
         </p:nvSpPr>
         <p:spPr>
           <a:xfrm>
-            <a:off x="5330952" y="2322576"/>
+            <a:off x="5422392" y="2322576"/>
             <a:ext cx="502920" cy="329184"/>
           </a:xfrm>
           <a:prstGeom prst="rect">
@@ -29298,7 +29298,7 @@
         </p:nvSpPr>
         <p:spPr>
           <a:xfrm>
-            <a:off x="5925312" y="2322576"/>
+            <a:off x="6035040" y="2322576"/>
             <a:ext cx="1325880" cy="329184"/>
           </a:xfrm>
           <a:prstGeom prst="rect">
@@ -29364,7 +29364,7 @@
         </p:nvSpPr>
         <p:spPr>
           <a:xfrm>
-            <a:off x="713232" y="2752344"/>
+            <a:off x="731520" y="2752344"/>
             <a:ext cx="2240280" cy="329184"/>
           </a:xfrm>
           <a:prstGeom prst="rect">
@@ -29403,7 +29403,7 @@
         </p:nvSpPr>
         <p:spPr>
           <a:xfrm>
-            <a:off x="3044952" y="2752344"/>
+            <a:off x="3081528" y="2752344"/>
             <a:ext cx="411480" cy="329184"/>
           </a:xfrm>
           <a:prstGeom prst="rect">
@@ -29442,7 +29442,7 @@
         </p:nvSpPr>
         <p:spPr>
           <a:xfrm>
-            <a:off x="3547872" y="2752344"/>
+            <a:off x="3602736" y="2752344"/>
             <a:ext cx="777240" cy="329184"/>
           </a:xfrm>
           <a:prstGeom prst="rect">
@@ -29481,7 +29481,7 @@
         </p:nvSpPr>
         <p:spPr>
           <a:xfrm>
-            <a:off x="4416552" y="2752344"/>
+            <a:off x="4489704" y="2752344"/>
             <a:ext cx="822960" cy="329184"/>
           </a:xfrm>
           <a:prstGeom prst="rect">
@@ -29520,7 +29520,7 @@
         </p:nvSpPr>
         <p:spPr>
           <a:xfrm>
-            <a:off x="5330952" y="2752344"/>
+            <a:off x="5422392" y="2752344"/>
             <a:ext cx="502920" cy="329184"/>
           </a:xfrm>
           <a:prstGeom prst="rect">
@@ -29559,7 +29559,7 @@
         </p:nvSpPr>
         <p:spPr>
           <a:xfrm>
-            <a:off x="5925312" y="2752344"/>
+            <a:off x="6035040" y="2752344"/>
             <a:ext cx="1325880" cy="329184"/>
           </a:xfrm>
           <a:prstGeom prst="rect">
@@ -29625,7 +29625,7 @@
         </p:nvSpPr>
         <p:spPr>
           <a:xfrm>
-            <a:off x="713232" y="3182112"/>
+            <a:off x="731520" y="3182112"/>
             <a:ext cx="2240280" cy="329184"/>
           </a:xfrm>
           <a:prstGeom prst="rect">
@@ -29664,7 +29664,7 @@
         </p:nvSpPr>
         <p:spPr>
           <a:xfrm>
-            <a:off x="3044952" y="3182112"/>
+            <a:off x="3081528" y="3182112"/>
             <a:ext cx="411480" cy="329184"/>
           </a:xfrm>
           <a:prstGeom prst="rect">
@@ -29703,7 +29703,7 @@
         </p:nvSpPr>
         <p:spPr>
           <a:xfrm>
-            <a:off x="3547872" y="3182112"/>
+            <a:off x="3602736" y="3182112"/>
             <a:ext cx="777240" cy="329184"/>
           </a:xfrm>
           <a:prstGeom prst="rect">
@@ -29742,7 +29742,7 @@
         </p:nvSpPr>
         <p:spPr>
           <a:xfrm>
-            <a:off x="4416552" y="3182112"/>
+            <a:off x="4489704" y="3182112"/>
             <a:ext cx="822960" cy="329184"/>
           </a:xfrm>
           <a:prstGeom prst="rect">
@@ -29781,7 +29781,7 @@
         </p:nvSpPr>
         <p:spPr>
           <a:xfrm>
-            <a:off x="5330952" y="3182112"/>
+            <a:off x="5422392" y="3182112"/>
             <a:ext cx="502920" cy="329184"/>
           </a:xfrm>
           <a:prstGeom prst="rect">
@@ -29820,7 +29820,7 @@
         </p:nvSpPr>
         <p:spPr>
           <a:xfrm>
-            <a:off x="5925312" y="3182112"/>
+            <a:off x="6035040" y="3182112"/>
             <a:ext cx="1325880" cy="329184"/>
           </a:xfrm>
           <a:prstGeom prst="rect">
@@ -29886,7 +29886,7 @@
         </p:nvSpPr>
         <p:spPr>
           <a:xfrm>
-            <a:off x="713232" y="3611880"/>
+            <a:off x="731520" y="3611880"/>
             <a:ext cx="2240280" cy="347472"/>
           </a:xfrm>
           <a:prstGeom prst="rect">
@@ -29925,7 +29925,7 @@
         </p:nvSpPr>
         <p:spPr>
           <a:xfrm>
-            <a:off x="3044952" y="3611880"/>
+            <a:off x="3081528" y="3611880"/>
             <a:ext cx="411480" cy="347472"/>
           </a:xfrm>
           <a:prstGeom prst="rect">
@@ -29964,7 +29964,7 @@
         </p:nvSpPr>
         <p:spPr>
           <a:xfrm>
-            <a:off x="3547872" y="3611880"/>
+            <a:off x="3602736" y="3611880"/>
             <a:ext cx="777240" cy="347472"/>
           </a:xfrm>
           <a:prstGeom prst="rect">
@@ -30003,7 +30003,7 @@
         </p:nvSpPr>
         <p:spPr>
           <a:xfrm>
-            <a:off x="4416552" y="3611880"/>
+            <a:off x="4489704" y="3611880"/>
             <a:ext cx="822960" cy="347472"/>
           </a:xfrm>
           <a:prstGeom prst="rect">
@@ -30042,7 +30042,7 @@
         </p:nvSpPr>
         <p:spPr>
           <a:xfrm>
-            <a:off x="5330952" y="3611880"/>
+            <a:off x="5422392" y="3611880"/>
             <a:ext cx="502920" cy="347472"/>
           </a:xfrm>
           <a:prstGeom prst="rect">
@@ -30081,7 +30081,7 @@
         </p:nvSpPr>
         <p:spPr>
           <a:xfrm>
-            <a:off x="5925312" y="3611880"/>
+            <a:off x="6035040" y="3611880"/>
             <a:ext cx="1325880" cy="347472"/>
           </a:xfrm>
           <a:prstGeom prst="rect">

</xml_diff>